<commit_message>
docs: update slide 4 analogy, slide 13 installation commands, and clean up handout draft notes
</commit_message>
<xml_diff>
--- a/study-group/2026-07-09-cli-ai-agents/slides.pptx
+++ b/study-group/2026-07-09-cli-ai-agents/slides.pptx
@@ -5119,15 +5119,7 @@
               <a:buNone/>
             </a:pPr>
             <a:r>
-              <a:rPr lang="en-US" sz="850" dirty="0">
-                <a:solidFill>
-                  <a:srgbClr val="35D399"/>
-                </a:solidFill>
-                <a:latin typeface="Courier New" pitchFamily="34" charset="0"/>
-                <a:ea typeface="Courier New" pitchFamily="34" charset="-122"/>
-                <a:cs typeface="Courier New" pitchFamily="34" charset="-120"/>
-              </a:rPr>
-              <a:t>irm https://claude.ai/install.ps1 | iex</a:t>
+              <a:t>powershell -ExecutionPolicy Bypass -c "irm https://claude.ai/install.ps1 | iex"</a:t>
             </a:r>
             <a:endParaRPr lang="en-US" sz="850" dirty="0"/>
           </a:p>
@@ -5464,15 +5456,7 @@
               <a:buNone/>
             </a:pPr>
             <a:r>
-              <a:rPr lang="en-US" sz="850" dirty="0">
-                <a:solidFill>
-                  <a:srgbClr val="35D399"/>
-                </a:solidFill>
-                <a:latin typeface="Courier New" pitchFamily="34" charset="0"/>
-                <a:ea typeface="Courier New" pitchFamily="34" charset="-122"/>
-                <a:cs typeface="Courier New" pitchFamily="34" charset="-120"/>
-              </a:rPr>
-              <a:t>irm https://chatgpt.com/codex/install.ps1 | iex</a:t>
+              <a:t>powershell -ExecutionPolicy Bypass -c "irm https://chatgpt.com/codex/install.ps1 | iex"</a:t>
             </a:r>
             <a:endParaRPr lang="en-US" sz="850" dirty="0"/>
           </a:p>
@@ -9364,7 +9348,7 @@
         </p:nvSpPr>
         <p:spPr>
           <a:xfrm>
-            <a:off x="640080" y="1681480"/>
+            <a:off x="640080" y="1818640"/>
             <a:ext cx="1234440" cy="1234440"/>
           </a:xfrm>
           <a:prstGeom prst="ellipse">
@@ -9391,7 +9375,7 @@
         </p:nvSpPr>
         <p:spPr>
           <a:xfrm>
-            <a:off x="640080" y="1681480"/>
+            <a:off x="640080" y="1818640"/>
             <a:ext cx="1234440" cy="1234440"/>
           </a:xfrm>
           <a:prstGeom prst="rect">
@@ -9430,7 +9414,7 @@
         </p:nvSpPr>
         <p:spPr>
           <a:xfrm>
-            <a:off x="1920240" y="1955800"/>
+            <a:off x="1920240" y="2092960"/>
             <a:ext cx="731520" cy="640080"/>
           </a:xfrm>
           <a:prstGeom prst="rect">
@@ -9469,7 +9453,7 @@
         </p:nvSpPr>
         <p:spPr>
           <a:xfrm>
-            <a:off x="2697480" y="1681480"/>
+            <a:off x="2697480" y="1818640"/>
             <a:ext cx="1234440" cy="1234440"/>
           </a:xfrm>
           <a:prstGeom prst="ellipse">
@@ -9496,7 +9480,7 @@
         </p:nvSpPr>
         <p:spPr>
           <a:xfrm>
-            <a:off x="2697480" y="1681480"/>
+            <a:off x="2697480" y="1818640"/>
             <a:ext cx="1234440" cy="1234440"/>
           </a:xfrm>
           <a:prstGeom prst="rect">
@@ -9535,7 +9519,7 @@
         </p:nvSpPr>
         <p:spPr>
           <a:xfrm>
-            <a:off x="3977640" y="1955800"/>
+            <a:off x="3977640" y="2092960"/>
             <a:ext cx="731520" cy="640080"/>
           </a:xfrm>
           <a:prstGeom prst="rect">
@@ -9574,7 +9558,7 @@
         </p:nvSpPr>
         <p:spPr>
           <a:xfrm>
-            <a:off x="4754880" y="1681480"/>
+            <a:off x="4754880" y="1818640"/>
             <a:ext cx="1234440" cy="1234440"/>
           </a:xfrm>
           <a:prstGeom prst="ellipse">
@@ -9601,7 +9585,7 @@
         </p:nvSpPr>
         <p:spPr>
           <a:xfrm>
-            <a:off x="4754880" y="1681480"/>
+            <a:off x="4754880" y="1818640"/>
             <a:ext cx="1234440" cy="1234440"/>
           </a:xfrm>
           <a:prstGeom prst="rect">
@@ -9640,7 +9624,7 @@
         </p:nvSpPr>
         <p:spPr>
           <a:xfrm>
-            <a:off x="6035040" y="1955800"/>
+            <a:off x="6035040" y="2092960"/>
             <a:ext cx="731520" cy="640080"/>
           </a:xfrm>
           <a:prstGeom prst="rect">
@@ -9679,7 +9663,7 @@
         </p:nvSpPr>
         <p:spPr>
           <a:xfrm>
-            <a:off x="6812280" y="1681480"/>
+            <a:off x="6812280" y="1818640"/>
             <a:ext cx="1234440" cy="1234440"/>
           </a:xfrm>
           <a:prstGeom prst="ellipse">
@@ -9706,7 +9690,7 @@
         </p:nvSpPr>
         <p:spPr>
           <a:xfrm>
-            <a:off x="6812280" y="1681480"/>
+            <a:off x="6812280" y="1818640"/>
             <a:ext cx="1234440" cy="1234440"/>
           </a:xfrm>
           <a:prstGeom prst="rect">
@@ -9925,8 +9909,8 @@
         </p:nvSpPr>
         <p:spPr>
           <a:xfrm>
-            <a:off x="508000" y="1219200"/>
-            <a:ext cx="8140700" cy="477054"/>
+            <a:off x="502920" y="1133167"/>
+            <a:ext cx="8140700" cy="754053"/>
           </a:xfrm>
           <a:prstGeom prst="rect">
             <a:avLst/>
@@ -9941,6 +9925,7 @@
           <a:p>
             <a:pPr marL="0" indent="0">
               <a:buNone/>
+              <a:defRPr/>
             </a:pPr>
             <a:r>
               <a:rPr lang="en-US" sz="1250" b="1" dirty="0">
@@ -10142,6 +10127,127 @@
               <a:ea typeface="Malgun Gothic" pitchFamily="34" charset="-122"/>
               <a:cs typeface="Malgun Gothic" pitchFamily="34" charset="-120"/>
             </a:endParaRPr>
+          </a:p>
+          <a:p>
+            <a:pPr>
+              <a:defRPr/>
+            </a:pPr>
+            <a:r>
+              <a:rPr sz="1100" dirty="0"/>
+              <a:t>💡 </a:t>
+            </a:r>
+            <a:r>
+              <a:rPr sz="1100" dirty="0" err="1"/>
+              <a:t>쉽게</a:t>
+            </a:r>
+            <a:r>
+              <a:rPr sz="1100" dirty="0"/>
+              <a:t> </a:t>
+            </a:r>
+            <a:r>
+              <a:rPr sz="1100" dirty="0" err="1"/>
+              <a:t>말해</a:t>
+            </a:r>
+            <a:r>
+              <a:rPr sz="1100" dirty="0"/>
+              <a:t>: </a:t>
+            </a:r>
+            <a:r>
+              <a:rPr sz="1100" dirty="0" err="1"/>
+              <a:t>하네스는</a:t>
+            </a:r>
+            <a:r>
+              <a:rPr sz="1100" dirty="0"/>
+              <a:t> '</a:t>
+            </a:r>
+            <a:r>
+              <a:rPr sz="1100" dirty="0" err="1"/>
+              <a:t>신입사원이</a:t>
+            </a:r>
+            <a:r>
+              <a:rPr sz="1100" dirty="0"/>
+              <a:t> </a:t>
+            </a:r>
+            <a:r>
+              <a:rPr sz="1100" dirty="0" err="1"/>
+              <a:t>일하는</a:t>
+            </a:r>
+            <a:r>
+              <a:rPr sz="1100" dirty="0"/>
+              <a:t> </a:t>
+            </a:r>
+            <a:r>
+              <a:rPr sz="1100" dirty="0" err="1"/>
+              <a:t>업무용</a:t>
+            </a:r>
+            <a:r>
+              <a:rPr sz="1100" dirty="0"/>
+              <a:t> </a:t>
+            </a:r>
+            <a:r>
+              <a:rPr sz="1100" dirty="0" err="1"/>
+              <a:t>노트북</a:t>
+            </a:r>
+            <a:r>
+              <a:rPr sz="1100" dirty="0"/>
+              <a:t>(</a:t>
+            </a:r>
+            <a:r>
+              <a:rPr sz="1100" dirty="0" err="1"/>
+              <a:t>기본</a:t>
+            </a:r>
+            <a:r>
+              <a:rPr sz="1100" dirty="0"/>
+              <a:t> </a:t>
+            </a:r>
+            <a:r>
+              <a:rPr sz="1100" dirty="0" err="1"/>
+              <a:t>환경</a:t>
+            </a:r>
+            <a:r>
+              <a:rPr sz="1100" dirty="0"/>
+              <a:t>)', </a:t>
+            </a:r>
+            <a:r>
+              <a:rPr sz="1100" dirty="0" err="1"/>
+              <a:t>오케스트레이터는</a:t>
+            </a:r>
+            <a:r>
+              <a:rPr sz="1100" dirty="0"/>
+              <a:t> '</a:t>
+            </a:r>
+            <a:r>
+              <a:rPr sz="1100" dirty="0" err="1"/>
+              <a:t>일을</a:t>
+            </a:r>
+            <a:r>
+              <a:rPr sz="1100" dirty="0"/>
+              <a:t> </a:t>
+            </a:r>
+            <a:r>
+              <a:rPr sz="1100" dirty="0" err="1"/>
+              <a:t>나눠주는</a:t>
+            </a:r>
+            <a:r>
+              <a:rPr sz="1100" dirty="0"/>
+              <a:t> </a:t>
+            </a:r>
+            <a:r>
+              <a:rPr sz="1100" dirty="0" err="1"/>
+              <a:t>팀장급</a:t>
+            </a:r>
+            <a:r>
+              <a:rPr sz="1100" dirty="0"/>
+              <a:t> </a:t>
+            </a:r>
+            <a:r>
+              <a:rPr sz="1100" dirty="0" err="1"/>
+              <a:t>분배기</a:t>
+            </a:r>
+            <a:r>
+              <a:rPr dirty="0"/>
+              <a:t>'</a:t>
+            </a:r>
           </a:p>
         </p:txBody>
       </p:sp>

</xml_diff>